<commit_message>
Fix chart axis ids (schema-valid)
</commit_message>
<xml_diff>
--- a/audience-2026-10-22/LLA_Who_Is_Our_Audience.pptx
+++ b/audience-2026-10-22/LLA_Who_Is_Our_Audience.pptx
@@ -265,12 +265,12 @@
           <c:showLeaderLines val="1"/>
         </c:dLbls>
         <c:gapWidth val="55"/>
-        <c:overlap val="-8"/>
-        <c:axId val="-2068027336"/>
-        <c:axId val="-2113994440"/>
+        <c:overlap val="8"/>
+        <c:axId val="2068027336"/>
+        <c:axId val="2113994440"/>
       </c:barChart>
       <c:catAx>
-        <c:axId val="-2068027336"/>
+        <c:axId val="2068027336"/>
         <c:scaling>
           <c:orientation val="minMax"/>
         </c:scaling>
@@ -300,7 +300,7 @@
             </a:pPr>
           </a:p>
         </c:txPr>
-        <c:crossAx val="-2113994440"/>
+        <c:crossAx val="2113994440"/>
         <c:crosses val="autoZero"/>
         <c:auto val="1"/>
         <c:lblAlgn val="ctr"/>
@@ -308,7 +308,7 @@
         <c:noMultiLvlLbl val="0"/>
       </c:catAx>
       <c:valAx>
-        <c:axId val="-2113994440"/>
+        <c:axId val="2113994440"/>
         <c:scaling>
           <c:max val="58.0"/>
           <c:min val="0.0"/>
@@ -318,7 +318,7 @@
         <c:majorTickMark val="out"/>
         <c:minorTickMark val="none"/>
         <c:tickLblPos val="nextTo"/>
-        <c:crossAx val="-2068027336"/>
+        <c:crossAx val="2068027336"/>
         <c:crosses val="autoZero"/>
       </c:valAx>
     </c:plotArea>

</xml_diff>

<commit_message>
Final: schema-valid chart, spaced bars
</commit_message>
<xml_diff>
--- a/audience-2026-10-22/LLA_Who_Is_Our_Audience.pptx
+++ b/audience-2026-10-22/LLA_Who_Is_Our_Audience.pptx
@@ -264,8 +264,8 @@
           <c:showBubbleSize val="0"/>
           <c:showLeaderLines val="1"/>
         </c:dLbls>
-        <c:gapWidth val="70"/>
-        <c:overlap val="30"/>
+        <c:gapWidth val="60"/>
+        <c:overlap val="-12"/>
         <c:axId val="2068027336"/>
         <c:axId val="2113994440"/>
       </c:barChart>

</xml_diff>

<commit_message>
Audience v3: Blueprint vs Masterclass, factual volumes, 3 slides
</commit_message>
<xml_diff>
--- a/audience-2026-10-22/LLA_Who_Is_Our_Audience.pptx
+++ b/audience-2026-10-22/LLA_Who_Is_Our_Audience.pptx
@@ -7,6 +7,7 @@
   <p:sldIdLst>
     <p:sldId id="256" r:id="rId7"/>
     <p:sldId id="257" r:id="rId8"/>
+    <p:sldId id="258" r:id="rId9"/>
   </p:sldIdLst>
   <p:sldSz cx="12191695" cy="6858000" type="screen4x3"/>
   <p:notesSz cx="6858000" cy="9144000"/>
@@ -126,7 +127,68 @@
               <c:strCache>
                 <c:ptCount val="1"/>
                 <c:pt idx="0">
-                  <c:v>Lead generation · leads</c:v>
+                  <c:v>Women</c:v>
+                </c:pt>
+              </c:strCache>
+            </c:strRef>
+          </c:tx>
+          <c:spPr>
+            <a:solidFill>
+              <a:srgbClr val="006EFF"/>
+            </a:solidFill>
+          </c:spPr>
+          <c:cat>
+            <c:strRef>
+              <c:f>Sheet1!$A$2:$A$5</c:f>
+              <c:strCache>
+                <c:ptCount val="4"/>
+                <c:pt idx="0">
+                  <c:v>Under 45</c:v>
+                </c:pt>
+                <c:pt idx="1">
+                  <c:v>45 to 54</c:v>
+                </c:pt>
+                <c:pt idx="2">
+                  <c:v>55 to 64</c:v>
+                </c:pt>
+                <c:pt idx="3">
+                  <c:v>65+</c:v>
+                </c:pt>
+              </c:strCache>
+            </c:strRef>
+          </c:cat>
+          <c:val>
+            <c:numRef>
+              <c:f>Sheet1!$B$2:$B$5</c:f>
+              <c:numCache>
+                <c:formatCode>General</c:formatCode>
+                <c:ptCount val="4"/>
+                <c:pt idx="0">
+                  <c:v>397.0</c:v>
+                </c:pt>
+                <c:pt idx="1">
+                  <c:v>968.0</c:v>
+                </c:pt>
+                <c:pt idx="2">
+                  <c:v>2130.0</c:v>
+                </c:pt>
+                <c:pt idx="3">
+                  <c:v>860.0</c:v>
+                </c:pt>
+              </c:numCache>
+            </c:numRef>
+          </c:val>
+        </c:ser>
+        <c:ser>
+          <c:idx val="1"/>
+          <c:order val="1"/>
+          <c:tx>
+            <c:strRef>
+              <c:f>Sheet1!$C$1</c:f>
+              <c:strCache>
+                <c:ptCount val="1"/>
+                <c:pt idx="0">
+                  <c:v>Men</c:v>
                 </c:pt>
               </c:strCache>
             </c:strRef>
@@ -158,89 +220,28 @@
           </c:cat>
           <c:val>
             <c:numRef>
-              <c:f>Sheet1!$B$2:$B$5</c:f>
-              <c:numCache>
-                <c:formatCode>General</c:formatCode>
-                <c:ptCount val="4"/>
-                <c:pt idx="0">
-                  <c:v>9.2</c:v>
-                </c:pt>
-                <c:pt idx="1">
-                  <c:v>21.4</c:v>
-                </c:pt>
-                <c:pt idx="2">
-                  <c:v>47.9</c:v>
-                </c:pt>
-                <c:pt idx="3">
-                  <c:v>21.4</c:v>
-                </c:pt>
-              </c:numCache>
-            </c:numRef>
-          </c:val>
-        </c:ser>
-        <c:ser>
-          <c:idx val="1"/>
-          <c:order val="1"/>
-          <c:tx>
-            <c:strRef>
-              <c:f>Sheet1!$C$1</c:f>
-              <c:strCache>
-                <c:ptCount val="1"/>
-                <c:pt idx="0">
-                  <c:v>Masterclass · buyers</c:v>
-                </c:pt>
-              </c:strCache>
-            </c:strRef>
-          </c:tx>
-          <c:spPr>
-            <a:solidFill>
-              <a:srgbClr val="006EFF"/>
-            </a:solidFill>
-          </c:spPr>
-          <c:cat>
-            <c:strRef>
-              <c:f>Sheet1!$A$2:$A$5</c:f>
-              <c:strCache>
-                <c:ptCount val="4"/>
-                <c:pt idx="0">
-                  <c:v>Under 45</c:v>
-                </c:pt>
-                <c:pt idx="1">
-                  <c:v>45 to 54</c:v>
-                </c:pt>
-                <c:pt idx="2">
-                  <c:v>55 to 64</c:v>
-                </c:pt>
-                <c:pt idx="3">
-                  <c:v>65+</c:v>
-                </c:pt>
-              </c:strCache>
-            </c:strRef>
-          </c:cat>
-          <c:val>
-            <c:numRef>
               <c:f>Sheet1!$C$2:$C$5</c:f>
               <c:numCache>
                 <c:formatCode>General</c:formatCode>
                 <c:ptCount val="4"/>
                 <c:pt idx="0">
-                  <c:v>2.8</c:v>
+                  <c:v>148.0</c:v>
                 </c:pt>
                 <c:pt idx="1">
-                  <c:v>13.4</c:v>
+                  <c:v>305.0</c:v>
                 </c:pt>
                 <c:pt idx="2">
-                  <c:v>38.0</c:v>
+                  <c:v>716.0</c:v>
                 </c:pt>
                 <c:pt idx="3">
-                  <c:v>45.8</c:v>
+                  <c:v>408.0</c:v>
                 </c:pt>
               </c:numCache>
             </c:numRef>
           </c:val>
         </c:ser>
         <c:dLbls>
-          <c:numFmt formatCode="0&quot;%&quot;" sourceLinked="0"/>
+          <c:numFmt formatCode="#,##0" sourceLinked="0"/>
           <c:txPr>
             <a:bodyPr/>
             <a:lstStyle/>
@@ -310,7 +311,7 @@
       <c:valAx>
         <c:axId val="2113994440"/>
         <c:scaling>
-          <c:max val="58.0"/>
+          <c:max val="2513.4"/>
           <c:min val="0.0"/>
         </c:scaling>
         <c:delete/>
@@ -330,7 +331,257 @@
         <a:lstStyle/>
         <a:p>
           <a:pPr>
-            <a:defRPr sz="1800">
+            <a:defRPr sz="2000">
+              <a:solidFill>
+                <a:srgbClr val="0F2445"/>
+              </a:solidFill>
+              <a:latin typeface="Poppins"/>
+            </a:defRPr>
+          </a:pPr>
+        </a:p>
+      </c:txPr>
+    </c:legend>
+    <c:dispBlanksAs val="gap"/>
+  </c:chart>
+  <c:txPr>
+    <a:bodyPr/>
+    <a:lstStyle/>
+    <a:p>
+      <a:pPr>
+        <a:defRPr sz="1800"/>
+      </a:pPr>
+      <a:endParaRPr lang="en-US"/>
+    </a:p>
+  </c:txPr>
+  <c:externalData r:id="rId1">
+    <c:autoUpdate val="0"/>
+  </c:externalData>
+</c:chartSpace>
+</file>
+
+<file path=ppt/charts/chart2.xml><?xml version="1.0" encoding="utf-8"?>
+<c:chartSpace xmlns:c="http://schemas.openxmlformats.org/drawingml/2006/chart" xmlns:a="http://schemas.openxmlformats.org/drawingml/2006/main" xmlns:r="http://schemas.openxmlformats.org/officeDocument/2006/relationships">
+  <c:date1904 val="0"/>
+  <c:chart>
+    <c:autoTitleDeleted val="0"/>
+    <c:plotArea>
+      <c:barChart>
+        <c:barDir val="col"/>
+        <c:grouping val="clustered"/>
+        <c:ser>
+          <c:idx val="0"/>
+          <c:order val="0"/>
+          <c:tx>
+            <c:strRef>
+              <c:f>Sheet1!$B$1</c:f>
+              <c:strCache>
+                <c:ptCount val="1"/>
+                <c:pt idx="0">
+                  <c:v>Women</c:v>
+                </c:pt>
+              </c:strCache>
+            </c:strRef>
+          </c:tx>
+          <c:spPr>
+            <a:solidFill>
+              <a:srgbClr val="006EFF"/>
+            </a:solidFill>
+          </c:spPr>
+          <c:cat>
+            <c:strRef>
+              <c:f>Sheet1!$A$2:$A$5</c:f>
+              <c:strCache>
+                <c:ptCount val="4"/>
+                <c:pt idx="0">
+                  <c:v>Under 45</c:v>
+                </c:pt>
+                <c:pt idx="1">
+                  <c:v>45 to 54</c:v>
+                </c:pt>
+                <c:pt idx="2">
+                  <c:v>55 to 64</c:v>
+                </c:pt>
+                <c:pt idx="3">
+                  <c:v>65+</c:v>
+                </c:pt>
+              </c:strCache>
+            </c:strRef>
+          </c:cat>
+          <c:val>
+            <c:numRef>
+              <c:f>Sheet1!$B$2:$B$5</c:f>
+              <c:numCache>
+                <c:formatCode>General</c:formatCode>
+                <c:ptCount val="4"/>
+                <c:pt idx="0">
+                  <c:v>1.0</c:v>
+                </c:pt>
+                <c:pt idx="1">
+                  <c:v>16.0</c:v>
+                </c:pt>
+                <c:pt idx="2">
+                  <c:v>43.0</c:v>
+                </c:pt>
+                <c:pt idx="3">
+                  <c:v>40.0</c:v>
+                </c:pt>
+              </c:numCache>
+            </c:numRef>
+          </c:val>
+        </c:ser>
+        <c:ser>
+          <c:idx val="1"/>
+          <c:order val="1"/>
+          <c:tx>
+            <c:strRef>
+              <c:f>Sheet1!$C$1</c:f>
+              <c:strCache>
+                <c:ptCount val="1"/>
+                <c:pt idx="0">
+                  <c:v>Men</c:v>
+                </c:pt>
+              </c:strCache>
+            </c:strRef>
+          </c:tx>
+          <c:spPr>
+            <a:solidFill>
+              <a:srgbClr val="5EB6FF"/>
+            </a:solidFill>
+          </c:spPr>
+          <c:cat>
+            <c:strRef>
+              <c:f>Sheet1!$A$2:$A$5</c:f>
+              <c:strCache>
+                <c:ptCount val="4"/>
+                <c:pt idx="0">
+                  <c:v>Under 45</c:v>
+                </c:pt>
+                <c:pt idx="1">
+                  <c:v>45 to 54</c:v>
+                </c:pt>
+                <c:pt idx="2">
+                  <c:v>55 to 64</c:v>
+                </c:pt>
+                <c:pt idx="3">
+                  <c:v>65+</c:v>
+                </c:pt>
+              </c:strCache>
+            </c:strRef>
+          </c:cat>
+          <c:val>
+            <c:numRef>
+              <c:f>Sheet1!$C$2:$C$5</c:f>
+              <c:numCache>
+                <c:formatCode>General</c:formatCode>
+                <c:ptCount val="4"/>
+                <c:pt idx="0">
+                  <c:v>3.0</c:v>
+                </c:pt>
+                <c:pt idx="1">
+                  <c:v>3.0</c:v>
+                </c:pt>
+                <c:pt idx="2">
+                  <c:v>11.0</c:v>
+                </c:pt>
+                <c:pt idx="3">
+                  <c:v>24.0</c:v>
+                </c:pt>
+              </c:numCache>
+            </c:numRef>
+          </c:val>
+        </c:ser>
+        <c:dLbls>
+          <c:numFmt formatCode="#,##0" sourceLinked="0"/>
+          <c:txPr>
+            <a:bodyPr/>
+            <a:lstStyle/>
+            <a:p>
+              <a:pPr>
+                <a:defRPr sz="2000" b="1">
+                  <a:solidFill>
+                    <a:srgbClr val="0F2445"/>
+                  </a:solidFill>
+                  <a:latin typeface="Poppins"/>
+                </a:defRPr>
+              </a:pPr>
+            </a:p>
+          </c:txPr>
+          <c:dLblPos val="outEnd"/>
+          <c:showLegendKey val="0"/>
+          <c:showVal val="1"/>
+          <c:showCatName val="0"/>
+          <c:showSerName val="0"/>
+          <c:showPercent val="0"/>
+          <c:showBubbleSize val="0"/>
+          <c:showLeaderLines val="1"/>
+        </c:dLbls>
+        <c:gapWidth val="60"/>
+        <c:overlap val="-12"/>
+        <c:axId val="2068027336"/>
+        <c:axId val="2113994440"/>
+      </c:barChart>
+      <c:catAx>
+        <c:axId val="2068027336"/>
+        <c:scaling>
+          <c:orientation val="minMax"/>
+        </c:scaling>
+        <c:delete val="0"/>
+        <c:axPos val="b"/>
+        <c:majorTickMark val="out"/>
+        <c:minorTickMark val="none"/>
+        <c:tickLblPos val="nextTo"/>
+        <c:spPr>
+          <a:ln>
+            <a:solidFill>
+              <a:srgbClr val="C9D6E8"/>
+            </a:solidFill>
+          </a:ln>
+        </c:spPr>
+        <c:txPr>
+          <a:bodyPr/>
+          <a:lstStyle/>
+          <a:p>
+            <a:pPr>
+              <a:defRPr sz="2000" b="1">
+                <a:solidFill>
+                  <a:srgbClr val="0F2445"/>
+                </a:solidFill>
+                <a:latin typeface="Poppins"/>
+              </a:defRPr>
+            </a:pPr>
+          </a:p>
+        </c:txPr>
+        <c:crossAx val="2113994440"/>
+        <c:crosses val="autoZero"/>
+        <c:auto val="1"/>
+        <c:lblAlgn val="ctr"/>
+        <c:lblOffset val="100"/>
+        <c:noMultiLvlLbl val="0"/>
+      </c:catAx>
+      <c:valAx>
+        <c:axId val="2113994440"/>
+        <c:scaling>
+          <c:max val="50.739999999999995"/>
+          <c:min val="0.0"/>
+        </c:scaling>
+        <c:delete/>
+        <c:axPos val="l"/>
+        <c:majorTickMark val="out"/>
+        <c:minorTickMark val="none"/>
+        <c:tickLblPos val="nextTo"/>
+        <c:crossAx val="2068027336"/>
+        <c:crosses val="autoZero"/>
+      </c:valAx>
+    </c:plotArea>
+    <c:legend>
+      <c:legendPos val="t"/>
+      <c:overlay val="0"/>
+      <c:txPr>
+        <a:bodyPr/>
+        <a:lstStyle/>
+        <a:p>
+          <a:pPr>
+            <a:defRPr sz="2000">
               <a:solidFill>
                 <a:srgbClr val="0F2445"/>
               </a:solidFill>
@@ -3369,7 +3620,7 @@
                 </a:solidFill>
                 <a:latin typeface="Poppins"/>
               </a:rPr>
-              <a:t>Longevity Life Academy · Who is our audience · 1 / 2</a:t>
+              <a:t>Longevity Blueprint · 18-week course, 5 × $179 · Meta Ads, May to Oct 2026</a:t>
             </a:r>
           </a:p>
         </p:txBody>
@@ -3404,7 +3655,7 @@
                 </a:solidFill>
                 <a:latin typeface="Poppins"/>
               </a:rPr>
-              <a:t>Our audience is a woman over 55 on Facebook. Paying buyers are older still.</a:t>
+              <a:t>Blueprint: 5,979 leads at $20 each. 73% women, 69% aged 55+.</a:t>
             </a:r>
           </a:p>
         </p:txBody>
@@ -3418,7 +3669,7 @@
         <p:spPr>
           <a:xfrm>
             <a:off x="548640" y="2011680"/>
-            <a:ext cx="5943600" cy="4206240"/>
+            <a:ext cx="6309360" cy="4297680"/>
           </a:xfrm>
           <a:prstGeom prst="roundRect">
             <a:avLst>
@@ -3462,8 +3713,8 @@
         </p:nvSpPr>
         <p:spPr>
           <a:xfrm>
-            <a:off x="822960" y="2148840"/>
-            <a:ext cx="5486400" cy="457200"/>
+            <a:off x="822959" y="2148840"/>
+            <a:ext cx="5760720" cy="457200"/>
           </a:xfrm>
           <a:prstGeom prst="rect">
             <a:avLst/>
@@ -3484,7 +3735,7 @@
                 </a:solidFill>
                 <a:latin typeface="Poppins"/>
               </a:rPr>
-              <a:t>Share of results by age</a:t>
+              <a:t>Blueprint leads by age and gender</a:t>
             </a:r>
           </a:p>
         </p:txBody>
@@ -3499,7 +3750,7 @@
         </p:nvGraphicFramePr>
         <p:xfrm>
           <a:off x="685800" y="2606040"/>
-          <a:ext cx="5669280" cy="3520440"/>
+          <a:ext cx="6035040" cy="3611880"/>
         </p:xfrm>
         <a:graphic>
           <a:graphicData uri="http://schemas.openxmlformats.org/drawingml/2006/chart">
@@ -3515,8 +3766,8 @@
         </p:nvSpPr>
         <p:spPr>
           <a:xfrm>
-            <a:off x="6675120" y="2011680"/>
-            <a:ext cx="4983480" cy="2057400"/>
+            <a:off x="6995160" y="2011680"/>
+            <a:ext cx="4663440" cy="1280160"/>
           </a:xfrm>
           <a:prstGeom prst="roundRect">
             <a:avLst>
@@ -3560,8 +3811,8 @@
         </p:nvSpPr>
         <p:spPr>
           <a:xfrm>
-            <a:off x="6949440" y="2176272"/>
-            <a:ext cx="4480560" cy="411480"/>
+            <a:off x="7251192" y="2157984"/>
+            <a:ext cx="4206240" cy="411480"/>
           </a:xfrm>
           <a:prstGeom prst="rect">
             <a:avLst/>
@@ -3582,7 +3833,7 @@
                 </a:solidFill>
                 <a:latin typeface="Poppins"/>
               </a:rPr>
-              <a:t>Lead generation · May to Oct</a:t>
+              <a:t>Who we target</a:t>
             </a:r>
           </a:p>
         </p:txBody>
@@ -3595,8 +3846,8 @@
         </p:nvSpPr>
         <p:spPr>
           <a:xfrm>
-            <a:off x="6949440" y="2514600"/>
-            <a:ext cx="4480560" cy="640080"/>
+            <a:off x="7251192" y="2578608"/>
+            <a:ext cx="4251959" cy="640080"/>
           </a:xfrm>
           <a:prstGeom prst="rect">
             <a:avLst/>
@@ -3611,38 +3862,15 @@
           <a:p>
             <a:pPr algn="l"/>
             <a:r>
-              <a:rPr sz="3600" b="1">
+              <a:rPr sz="2000" b="0">
                 <a:solidFill>
                   <a:srgbClr val="0F2445"/>
                 </a:solidFill>
                 <a:latin typeface="Poppins"/>
               </a:rPr>
-              <a:t>5,979 leads</a:t>
-            </a:r>
-          </a:p>
-        </p:txBody>
-      </p:sp>
-      <p:sp>
-        <p:nvSpPr>
-          <p:cNvPr id="10" name="TextBox 9"/>
-          <p:cNvSpPr txBox="1"/>
-          <p:nvPr/>
-        </p:nvSpPr>
-        <p:spPr>
-          <a:xfrm>
-            <a:off x="6949440" y="3108960"/>
-            <a:ext cx="4526280" cy="914400"/>
-          </a:xfrm>
-          <a:prstGeom prst="rect">
-            <a:avLst/>
-          </a:prstGeom>
-          <a:noFill/>
-        </p:spPr>
-        <p:txBody>
-          <a:bodyPr wrap="square" lIns="0" rIns="0" tIns="0" bIns="0" anchor="t">
-            <a:spAutoFit/>
-          </a:bodyPr>
-          <a:lstStyle/>
+              <a:t>US, ages 35 to 64</a:t>
+            </a:r>
+          </a:p>
           <a:p>
             <a:pPr algn="l"/>
             <a:r>
@@ -3652,45 +3880,21 @@
                 </a:solidFill>
                 <a:latin typeface="Poppins"/>
               </a:rPr>
-              <a:t>73% women · 69% aged 55+</a:t>
-            </a:r>
-          </a:p>
-          <a:p>
-            <a:pPr algn="l"/>
-            <a:r>
-              <a:rPr sz="2000" b="0">
-                <a:solidFill>
-                  <a:srgbClr val="0F2445"/>
-                </a:solidFill>
-                <a:latin typeface="Poppins"/>
-              </a:rPr>
-              <a:t>92% Facebook · 75% iPhone</a:t>
-            </a:r>
-          </a:p>
-          <a:p>
-            <a:pPr algn="l"/>
-            <a:r>
-              <a:rPr sz="2000" b="1">
-                <a:solidFill>
-                  <a:srgbClr val="006EFF"/>
-                </a:solidFill>
-                <a:latin typeface="Poppins"/>
-              </a:rPr>
-              <a:t>Women 55 to 64: 36% of leads</a:t>
-            </a:r>
-          </a:p>
-        </p:txBody>
-      </p:sp>
-      <p:sp>
-        <p:nvSpPr>
-          <p:cNvPr id="11" name="Rounded Rectangle 10"/>
+              <a:t>12 interests, top-income ZIPs</a:t>
+            </a:r>
+          </a:p>
+        </p:txBody>
+      </p:sp>
+      <p:sp>
+        <p:nvSpPr>
+          <p:cNvPr id="10" name="Rounded Rectangle 9"/>
           <p:cNvSpPr/>
           <p:nvPr/>
         </p:nvSpPr>
         <p:spPr>
           <a:xfrm>
-            <a:off x="6675120" y="4160520"/>
-            <a:ext cx="4983480" cy="2057400"/>
+            <a:off x="6995160" y="3410712"/>
+            <a:ext cx="4663440" cy="1280160"/>
           </a:xfrm>
           <a:prstGeom prst="roundRect">
             <a:avLst>
@@ -3698,7 +3902,7 @@
             </a:avLst>
           </a:prstGeom>
           <a:solidFill>
-            <a:srgbClr val="E3F3EA"/>
+            <a:srgbClr val="EEF4FC"/>
           </a:solidFill>
           <a:ln>
             <a:noFill/>
@@ -3728,14 +3932,14 @@
       </p:sp>
       <p:sp>
         <p:nvSpPr>
-          <p:cNvPr id="12" name="TextBox 11"/>
+          <p:cNvPr id="11" name="TextBox 10"/>
           <p:cNvSpPr txBox="1"/>
           <p:nvPr/>
         </p:nvSpPr>
         <p:spPr>
           <a:xfrm>
-            <a:off x="6949440" y="4325112"/>
-            <a:ext cx="4480560" cy="411480"/>
+            <a:off x="7251192" y="3557016"/>
+            <a:ext cx="4206240" cy="411480"/>
           </a:xfrm>
           <a:prstGeom prst="rect">
             <a:avLst/>
@@ -3752,25 +3956,25 @@
             <a:r>
               <a:rPr sz="2000" b="1">
                 <a:solidFill>
-                  <a:srgbClr val="0E7A4B"/>
+                  <a:srgbClr val="006EFF"/>
                 </a:solidFill>
                 <a:latin typeface="Poppins"/>
               </a:rPr>
-              <a:t>Masterclass · Sep to Oct</a:t>
-            </a:r>
-          </a:p>
-        </p:txBody>
-      </p:sp>
-      <p:sp>
-        <p:nvSpPr>
-          <p:cNvPr id="13" name="TextBox 12"/>
+              <a:t>Who converts most</a:t>
+            </a:r>
+          </a:p>
+        </p:txBody>
+      </p:sp>
+      <p:sp>
+        <p:nvSpPr>
+          <p:cNvPr id="12" name="TextBox 11"/>
           <p:cNvSpPr txBox="1"/>
           <p:nvPr/>
         </p:nvSpPr>
         <p:spPr>
           <a:xfrm>
-            <a:off x="6949440" y="4663440"/>
-            <a:ext cx="4480560" cy="640080"/>
+            <a:off x="7251192" y="3977639"/>
+            <a:ext cx="4251959" cy="640080"/>
           </a:xfrm>
           <a:prstGeom prst="rect">
             <a:avLst/>
@@ -3785,14 +3989,71 @@
           <a:p>
             <a:pPr algn="l"/>
             <a:r>
-              <a:rPr sz="3600" b="1">
+              <a:rPr sz="2000" b="0">
                 <a:solidFill>
                   <a:srgbClr val="0F2445"/>
                 </a:solidFill>
                 <a:latin typeface="Poppins"/>
               </a:rPr>
-              <a:t>142 buyers</a:t>
-            </a:r>
+              <a:t>Women 55 to 64: 2,130 leads</a:t>
+            </a:r>
+          </a:p>
+          <a:p>
+            <a:pPr algn="l"/>
+            <a:r>
+              <a:rPr sz="2000" b="0">
+                <a:solidFill>
+                  <a:srgbClr val="0F2445"/>
+                </a:solidFill>
+                <a:latin typeface="Poppins"/>
+              </a:rPr>
+              <a:t>Lowest cost: men 65+, $18</a:t>
+            </a:r>
+          </a:p>
+        </p:txBody>
+      </p:sp>
+      <p:sp>
+        <p:nvSpPr>
+          <p:cNvPr id="13" name="Rounded Rectangle 12"/>
+          <p:cNvSpPr/>
+          <p:nvPr/>
+        </p:nvSpPr>
+        <p:spPr>
+          <a:xfrm>
+            <a:off x="6995160" y="4809744"/>
+            <a:ext cx="4663440" cy="1499616"/>
+          </a:xfrm>
+          <a:prstGeom prst="roundRect">
+            <a:avLst>
+              <a:gd name="adj" fmla="val 6000"/>
+            </a:avLst>
+          </a:prstGeom>
+          <a:solidFill>
+            <a:srgbClr val="E3F3EA"/>
+          </a:solidFill>
+          <a:ln>
+            <a:noFill/>
+          </a:ln>
+        </p:spPr>
+        <p:style>
+          <a:lnRef idx="1">
+            <a:schemeClr val="accent1"/>
+          </a:lnRef>
+          <a:fillRef idx="3">
+            <a:schemeClr val="accent1"/>
+          </a:fillRef>
+          <a:effectRef idx="2">
+            <a:schemeClr val="accent1"/>
+          </a:effectRef>
+          <a:fontRef idx="minor">
+            <a:schemeClr val="lt1"/>
+          </a:fontRef>
+        </p:style>
+        <p:txBody>
+          <a:bodyPr rtlCol="0" anchor="ctr"/>
+          <a:lstStyle/>
+          <a:p>
+            <a:pPr algn="ctr"/>
           </a:p>
         </p:txBody>
       </p:sp>
@@ -3804,8 +4065,8 @@
         </p:nvSpPr>
         <p:spPr>
           <a:xfrm>
-            <a:off x="6949440" y="5257800"/>
-            <a:ext cx="4526280" cy="914400"/>
+            <a:off x="7251192" y="4956048"/>
+            <a:ext cx="4206240" cy="411480"/>
           </a:xfrm>
           <a:prstGeom prst="rect">
             <a:avLst/>
@@ -3820,37 +4081,13 @@
           <a:p>
             <a:pPr algn="l"/>
             <a:r>
-              <a:rPr sz="2000" b="0">
-                <a:solidFill>
-                  <a:srgbClr val="0F2445"/>
+              <a:rPr sz="2000" b="1">
+                <a:solidFill>
+                  <a:srgbClr val="0E7A4B"/>
                 </a:solidFill>
                 <a:latin typeface="Poppins"/>
               </a:rPr>
-              <a:t>70% women · 84% aged 55+</a:t>
-            </a:r>
-          </a:p>
-          <a:p>
-            <a:pPr algn="l"/>
-            <a:r>
-              <a:rPr sz="2000" b="0">
-                <a:solidFill>
-                  <a:srgbClr val="0F2445"/>
-                </a:solidFill>
-                <a:latin typeface="Poppins"/>
-              </a:rPr>
-              <a:t>99% Facebook · 92% iPhone</a:t>
-            </a:r>
-          </a:p>
-          <a:p>
-            <a:pPr algn="l"/>
-            <a:r>
-              <a:rPr sz="2000" b="1">
-                <a:solidFill>
-                  <a:srgbClr val="0E7A4B"/>
-                </a:solidFill>
-                <a:latin typeface="Poppins"/>
-              </a:rPr>
-              <a:t>Cheapest buyer: men 65+</a:t>
+              <a:t>Direct online purchases</a:t>
             </a:r>
           </a:p>
         </p:txBody>
@@ -3863,8 +4100,8 @@
         </p:nvSpPr>
         <p:spPr>
           <a:xfrm>
-            <a:off x="548640" y="6355080"/>
-            <a:ext cx="11064240" cy="365760"/>
+            <a:off x="7251192" y="5376672"/>
+            <a:ext cx="4251959" cy="859536"/>
           </a:xfrm>
           <a:prstGeom prst="rect">
             <a:avLst/>
@@ -3879,13 +4116,60 @@
           <a:p>
             <a:pPr algn="l"/>
             <a:r>
-              <a:rPr sz="1800" b="0">
-                <a:solidFill>
-                  <a:srgbClr val="4A5A72"/>
+              <a:rPr sz="2000" b="0">
+                <a:solidFill>
+                  <a:srgbClr val="0F2445"/>
                 </a:solidFill>
                 <a:latin typeface="Poppins"/>
               </a:rPr>
-              <a:t>Source: Meta Ads, 11 May to 22 Oct 2026. Buyers are Meta-attributed purchases.</a:t>
+              <a:t>3 purchases from $28,254</a:t>
+            </a:r>
+          </a:p>
+          <a:p>
+            <a:pPr algn="l"/>
+            <a:r>
+              <a:rPr sz="2000" b="0">
+                <a:solidFill>
+                  <a:srgbClr val="0F2445"/>
+                </a:solidFill>
+                <a:latin typeface="Poppins"/>
+              </a:rPr>
+              <a:t>Leads are closed by sales team</a:t>
+            </a:r>
+          </a:p>
+        </p:txBody>
+      </p:sp>
+      <p:sp>
+        <p:nvSpPr>
+          <p:cNvPr id="16" name="TextBox 15"/>
+          <p:cNvSpPr txBox="1"/>
+          <p:nvPr/>
+        </p:nvSpPr>
+        <p:spPr>
+          <a:xfrm>
+            <a:off x="548640" y="6355080"/>
+            <a:ext cx="11064240" cy="365760"/>
+          </a:xfrm>
+          <a:prstGeom prst="rect">
+            <a:avLst/>
+          </a:prstGeom>
+          <a:noFill/>
+        </p:spPr>
+        <p:txBody>
+          <a:bodyPr wrap="square" lIns="0" rIns="0" tIns="0" bIns="0" anchor="t">
+            <a:spAutoFit/>
+          </a:bodyPr>
+          <a:lstStyle/>
+          <a:p>
+            <a:pPr algn="l"/>
+            <a:r>
+              <a:rPr sz="1800" b="0">
+                <a:solidFill>
+                  <a:srgbClr val="4A5A72"/>
+                </a:solidFill>
+                <a:latin typeface="Poppins"/>
+              </a:rPr>
+              <a:t>Source: Meta Ads. 3 lead campaigns, $119,273 spend. 2 direct-sales campaigns, $28,254 spend.</a:t>
             </a:r>
           </a:p>
         </p:txBody>
@@ -3938,7 +4222,7 @@
                 </a:solidFill>
                 <a:latin typeface="Poppins"/>
               </a:rPr>
-              <a:t>Who we target · 2 / 2 · Masterclass · US only, ages 35 to 65+, top 10% income ZIPs</a:t>
+              <a:t>Julie Masterclass · $49 Standard, $79 VIP · Meta Ads, 24 Sep to 22 Oct 2026</a:t>
             </a:r>
           </a:p>
         </p:txBody>
@@ -3973,7 +4257,609 @@
                 </a:solidFill>
                 <a:latin typeface="Poppins"/>
               </a:rPr>
-              <a:t>41 interests in 6 clusters, plus lookalikes of our own paid buyers.</a:t>
+              <a:t>Masterclass: 142 buyers from $53,764. 70% women, 84% aged 55+.</a:t>
+            </a:r>
+          </a:p>
+        </p:txBody>
+      </p:sp>
+      <p:sp>
+        <p:nvSpPr>
+          <p:cNvPr id="4" name="Rounded Rectangle 3"/>
+          <p:cNvSpPr/>
+          <p:nvPr/>
+        </p:nvSpPr>
+        <p:spPr>
+          <a:xfrm>
+            <a:off x="548640" y="2011680"/>
+            <a:ext cx="6309360" cy="4297680"/>
+          </a:xfrm>
+          <a:prstGeom prst="roundRect">
+            <a:avLst>
+              <a:gd name="adj" fmla="val 6000"/>
+            </a:avLst>
+          </a:prstGeom>
+          <a:solidFill>
+            <a:srgbClr val="EEF4FC"/>
+          </a:solidFill>
+          <a:ln>
+            <a:noFill/>
+          </a:ln>
+        </p:spPr>
+        <p:style>
+          <a:lnRef idx="1">
+            <a:schemeClr val="accent1"/>
+          </a:lnRef>
+          <a:fillRef idx="3">
+            <a:schemeClr val="accent1"/>
+          </a:fillRef>
+          <a:effectRef idx="2">
+            <a:schemeClr val="accent1"/>
+          </a:effectRef>
+          <a:fontRef idx="minor">
+            <a:schemeClr val="lt1"/>
+          </a:fontRef>
+        </p:style>
+        <p:txBody>
+          <a:bodyPr rtlCol="0" anchor="ctr"/>
+          <a:lstStyle/>
+          <a:p>
+            <a:pPr algn="ctr"/>
+          </a:p>
+        </p:txBody>
+      </p:sp>
+      <p:sp>
+        <p:nvSpPr>
+          <p:cNvPr id="5" name="TextBox 4"/>
+          <p:cNvSpPr txBox="1"/>
+          <p:nvPr/>
+        </p:nvSpPr>
+        <p:spPr>
+          <a:xfrm>
+            <a:off x="822959" y="2148840"/>
+            <a:ext cx="5760720" cy="457200"/>
+          </a:xfrm>
+          <a:prstGeom prst="rect">
+            <a:avLst/>
+          </a:prstGeom>
+          <a:noFill/>
+        </p:spPr>
+        <p:txBody>
+          <a:bodyPr wrap="square" lIns="0" rIns="0" tIns="0" bIns="0" anchor="t">
+            <a:spAutoFit/>
+          </a:bodyPr>
+          <a:lstStyle/>
+          <a:p>
+            <a:pPr algn="l"/>
+            <a:r>
+              <a:rPr sz="2200" b="1">
+                <a:solidFill>
+                  <a:srgbClr val="0F2445"/>
+                </a:solidFill>
+                <a:latin typeface="Poppins"/>
+              </a:rPr>
+              <a:t>Masterclass buyers by age and gender</a:t>
+            </a:r>
+          </a:p>
+        </p:txBody>
+      </p:sp>
+      <p:graphicFrame>
+        <p:nvGraphicFramePr>
+          <p:cNvPr id="6" name="Chart 5"/>
+          <p:cNvGraphicFramePr>
+            <a:graphicFrameLocks noGrp="1"/>
+          </p:cNvGraphicFramePr>
+          <p:nvPr/>
+        </p:nvGraphicFramePr>
+        <p:xfrm>
+          <a:off x="685800" y="2606040"/>
+          <a:ext cx="6035040" cy="3611880"/>
+        </p:xfrm>
+        <a:graphic>
+          <a:graphicData uri="http://schemas.openxmlformats.org/drawingml/2006/chart">
+            <c:chart xmlns:c="http://schemas.openxmlformats.org/drawingml/2006/chart" r:id="rId2"/>
+          </a:graphicData>
+        </a:graphic>
+      </p:graphicFrame>
+      <p:sp>
+        <p:nvSpPr>
+          <p:cNvPr id="7" name="Rounded Rectangle 6"/>
+          <p:cNvSpPr/>
+          <p:nvPr/>
+        </p:nvSpPr>
+        <p:spPr>
+          <a:xfrm>
+            <a:off x="6995160" y="2011680"/>
+            <a:ext cx="4663440" cy="1828800"/>
+          </a:xfrm>
+          <a:prstGeom prst="roundRect">
+            <a:avLst>
+              <a:gd name="adj" fmla="val 6000"/>
+            </a:avLst>
+          </a:prstGeom>
+          <a:solidFill>
+            <a:srgbClr val="E3F3EA"/>
+          </a:solidFill>
+          <a:ln>
+            <a:noFill/>
+          </a:ln>
+        </p:spPr>
+        <p:style>
+          <a:lnRef idx="1">
+            <a:schemeClr val="accent1"/>
+          </a:lnRef>
+          <a:fillRef idx="3">
+            <a:schemeClr val="accent1"/>
+          </a:fillRef>
+          <a:effectRef idx="2">
+            <a:schemeClr val="accent1"/>
+          </a:effectRef>
+          <a:fontRef idx="minor">
+            <a:schemeClr val="lt1"/>
+          </a:fontRef>
+        </p:style>
+        <p:txBody>
+          <a:bodyPr rtlCol="0" anchor="ctr"/>
+          <a:lstStyle/>
+          <a:p>
+            <a:pPr algn="ctr"/>
+          </a:p>
+        </p:txBody>
+      </p:sp>
+      <p:sp>
+        <p:nvSpPr>
+          <p:cNvPr id="8" name="TextBox 7"/>
+          <p:cNvSpPr txBox="1"/>
+          <p:nvPr/>
+        </p:nvSpPr>
+        <p:spPr>
+          <a:xfrm>
+            <a:off x="7251192" y="2157984"/>
+            <a:ext cx="4206240" cy="411480"/>
+          </a:xfrm>
+          <a:prstGeom prst="rect">
+            <a:avLst/>
+          </a:prstGeom>
+          <a:noFill/>
+        </p:spPr>
+        <p:txBody>
+          <a:bodyPr wrap="square" lIns="0" rIns="0" tIns="0" bIns="0" anchor="t">
+            <a:spAutoFit/>
+          </a:bodyPr>
+          <a:lstStyle/>
+          <a:p>
+            <a:pPr algn="l"/>
+            <a:r>
+              <a:rPr sz="2000" b="1">
+                <a:solidFill>
+                  <a:srgbClr val="0E7A4B"/>
+                </a:solidFill>
+                <a:latin typeface="Poppins"/>
+              </a:rPr>
+              <a:t>Lowest cost per buyer</a:t>
+            </a:r>
+          </a:p>
+        </p:txBody>
+      </p:sp>
+      <p:sp>
+        <p:nvSpPr>
+          <p:cNvPr id="9" name="TextBox 8"/>
+          <p:cNvSpPr txBox="1"/>
+          <p:nvPr/>
+        </p:nvSpPr>
+        <p:spPr>
+          <a:xfrm>
+            <a:off x="7251192" y="2578608"/>
+            <a:ext cx="4251959" cy="1188720"/>
+          </a:xfrm>
+          <a:prstGeom prst="rect">
+            <a:avLst/>
+          </a:prstGeom>
+          <a:noFill/>
+        </p:spPr>
+        <p:txBody>
+          <a:bodyPr wrap="square" lIns="0" rIns="0" tIns="0" bIns="0" anchor="t">
+            <a:spAutoFit/>
+          </a:bodyPr>
+          <a:lstStyle/>
+          <a:p>
+            <a:pPr algn="l"/>
+            <a:r>
+              <a:rPr sz="2000" b="0">
+                <a:solidFill>
+                  <a:srgbClr val="0F2445"/>
+                </a:solidFill>
+                <a:latin typeface="Poppins"/>
+              </a:rPr>
+              <a:t>Men 65+: 24 at $320</a:t>
+            </a:r>
+          </a:p>
+          <a:p>
+            <a:pPr algn="l"/>
+            <a:r>
+              <a:rPr sz="2000" b="0">
+                <a:solidFill>
+                  <a:srgbClr val="0F2445"/>
+                </a:solidFill>
+                <a:latin typeface="Poppins"/>
+              </a:rPr>
+              <a:t>Women 55 to 64: 43 at $338</a:t>
+            </a:r>
+          </a:p>
+          <a:p>
+            <a:pPr algn="l"/>
+            <a:r>
+              <a:rPr sz="2000" b="0">
+                <a:solidFill>
+                  <a:srgbClr val="0F2445"/>
+                </a:solidFill>
+                <a:latin typeface="Poppins"/>
+              </a:rPr>
+              <a:t>Women 65+: 40 at $419</a:t>
+            </a:r>
+          </a:p>
+        </p:txBody>
+      </p:sp>
+      <p:sp>
+        <p:nvSpPr>
+          <p:cNvPr id="10" name="Rounded Rectangle 9"/>
+          <p:cNvSpPr/>
+          <p:nvPr/>
+        </p:nvSpPr>
+        <p:spPr>
+          <a:xfrm>
+            <a:off x="6995160" y="3959352"/>
+            <a:ext cx="4663440" cy="1280160"/>
+          </a:xfrm>
+          <a:prstGeom prst="roundRect">
+            <a:avLst>
+              <a:gd name="adj" fmla="val 6000"/>
+            </a:avLst>
+          </a:prstGeom>
+          <a:solidFill>
+            <a:srgbClr val="EEF4FC"/>
+          </a:solidFill>
+          <a:ln>
+            <a:noFill/>
+          </a:ln>
+        </p:spPr>
+        <p:style>
+          <a:lnRef idx="1">
+            <a:schemeClr val="accent1"/>
+          </a:lnRef>
+          <a:fillRef idx="3">
+            <a:schemeClr val="accent1"/>
+          </a:fillRef>
+          <a:effectRef idx="2">
+            <a:schemeClr val="accent1"/>
+          </a:effectRef>
+          <a:fontRef idx="minor">
+            <a:schemeClr val="lt1"/>
+          </a:fontRef>
+        </p:style>
+        <p:txBody>
+          <a:bodyPr rtlCol="0" anchor="ctr"/>
+          <a:lstStyle/>
+          <a:p>
+            <a:pPr algn="ctr"/>
+          </a:p>
+        </p:txBody>
+      </p:sp>
+      <p:sp>
+        <p:nvSpPr>
+          <p:cNvPr id="11" name="TextBox 10"/>
+          <p:cNvSpPr txBox="1"/>
+          <p:nvPr/>
+        </p:nvSpPr>
+        <p:spPr>
+          <a:xfrm>
+            <a:off x="7251192" y="4105656"/>
+            <a:ext cx="4206240" cy="411480"/>
+          </a:xfrm>
+          <a:prstGeom prst="rect">
+            <a:avLst/>
+          </a:prstGeom>
+          <a:noFill/>
+        </p:spPr>
+        <p:txBody>
+          <a:bodyPr wrap="square" lIns="0" rIns="0" tIns="0" bIns="0" anchor="t">
+            <a:spAutoFit/>
+          </a:bodyPr>
+          <a:lstStyle/>
+          <a:p>
+            <a:pPr algn="l"/>
+            <a:r>
+              <a:rPr sz="2000" b="1">
+                <a:solidFill>
+                  <a:srgbClr val="006EFF"/>
+                </a:solidFill>
+                <a:latin typeface="Poppins"/>
+              </a:rPr>
+              <a:t>Who we target</a:t>
+            </a:r>
+          </a:p>
+        </p:txBody>
+      </p:sp>
+      <p:sp>
+        <p:nvSpPr>
+          <p:cNvPr id="12" name="TextBox 11"/>
+          <p:cNvSpPr txBox="1"/>
+          <p:nvPr/>
+        </p:nvSpPr>
+        <p:spPr>
+          <a:xfrm>
+            <a:off x="7251192" y="4526280"/>
+            <a:ext cx="4251959" cy="640080"/>
+          </a:xfrm>
+          <a:prstGeom prst="rect">
+            <a:avLst/>
+          </a:prstGeom>
+          <a:noFill/>
+        </p:spPr>
+        <p:txBody>
+          <a:bodyPr wrap="square" lIns="0" rIns="0" tIns="0" bIns="0" anchor="t">
+            <a:spAutoFit/>
+          </a:bodyPr>
+          <a:lstStyle/>
+          <a:p>
+            <a:pPr algn="l"/>
+            <a:r>
+              <a:rPr sz="2000" b="0">
+                <a:solidFill>
+                  <a:srgbClr val="0F2445"/>
+                </a:solidFill>
+                <a:latin typeface="Poppins"/>
+              </a:rPr>
+              <a:t>US, ages 35 to 65+, 41 interests</a:t>
+            </a:r>
+          </a:p>
+          <a:p>
+            <a:pPr algn="l"/>
+            <a:r>
+              <a:rPr sz="2000" b="0">
+                <a:solidFill>
+                  <a:srgbClr val="0F2445"/>
+                </a:solidFill>
+                <a:latin typeface="Poppins"/>
+              </a:rPr>
+              <a:t>plus lookalikes of our buyers</a:t>
+            </a:r>
+          </a:p>
+        </p:txBody>
+      </p:sp>
+      <p:sp>
+        <p:nvSpPr>
+          <p:cNvPr id="13" name="Rounded Rectangle 12"/>
+          <p:cNvSpPr/>
+          <p:nvPr/>
+        </p:nvSpPr>
+        <p:spPr>
+          <a:xfrm>
+            <a:off x="6995160" y="5358384"/>
+            <a:ext cx="4663440" cy="950976"/>
+          </a:xfrm>
+          <a:prstGeom prst="roundRect">
+            <a:avLst>
+              <a:gd name="adj" fmla="val 6000"/>
+            </a:avLst>
+          </a:prstGeom>
+          <a:solidFill>
+            <a:srgbClr val="EEF4FC"/>
+          </a:solidFill>
+          <a:ln>
+            <a:noFill/>
+          </a:ln>
+        </p:spPr>
+        <p:style>
+          <a:lnRef idx="1">
+            <a:schemeClr val="accent1"/>
+          </a:lnRef>
+          <a:fillRef idx="3">
+            <a:schemeClr val="accent1"/>
+          </a:fillRef>
+          <a:effectRef idx="2">
+            <a:schemeClr val="accent1"/>
+          </a:effectRef>
+          <a:fontRef idx="minor">
+            <a:schemeClr val="lt1"/>
+          </a:fontRef>
+        </p:style>
+        <p:txBody>
+          <a:bodyPr rtlCol="0" anchor="ctr"/>
+          <a:lstStyle/>
+          <a:p>
+            <a:pPr algn="ctr"/>
+          </a:p>
+        </p:txBody>
+      </p:sp>
+      <p:sp>
+        <p:nvSpPr>
+          <p:cNvPr id="14" name="TextBox 13"/>
+          <p:cNvSpPr txBox="1"/>
+          <p:nvPr/>
+        </p:nvSpPr>
+        <p:spPr>
+          <a:xfrm>
+            <a:off x="7251192" y="5504688"/>
+            <a:ext cx="4206240" cy="411480"/>
+          </a:xfrm>
+          <a:prstGeom prst="rect">
+            <a:avLst/>
+          </a:prstGeom>
+          <a:noFill/>
+        </p:spPr>
+        <p:txBody>
+          <a:bodyPr wrap="square" lIns="0" rIns="0" tIns="0" bIns="0" anchor="t">
+            <a:spAutoFit/>
+          </a:bodyPr>
+          <a:lstStyle/>
+          <a:p>
+            <a:pPr algn="l"/>
+            <a:r>
+              <a:rPr sz="2000" b="1">
+                <a:solidFill>
+                  <a:srgbClr val="006EFF"/>
+                </a:solidFill>
+                <a:latin typeface="Poppins"/>
+              </a:rPr>
+              <a:t>Versus Blueprint leads</a:t>
+            </a:r>
+          </a:p>
+        </p:txBody>
+      </p:sp>
+      <p:sp>
+        <p:nvSpPr>
+          <p:cNvPr id="15" name="TextBox 14"/>
+          <p:cNvSpPr txBox="1"/>
+          <p:nvPr/>
+        </p:nvSpPr>
+        <p:spPr>
+          <a:xfrm>
+            <a:off x="7251192" y="5925312"/>
+            <a:ext cx="4251959" cy="310896"/>
+          </a:xfrm>
+          <a:prstGeom prst="rect">
+            <a:avLst/>
+          </a:prstGeom>
+          <a:noFill/>
+        </p:spPr>
+        <p:txBody>
+          <a:bodyPr wrap="square" lIns="0" rIns="0" tIns="0" bIns="0" anchor="t">
+            <a:spAutoFit/>
+          </a:bodyPr>
+          <a:lstStyle/>
+          <a:p>
+            <a:pPr algn="l"/>
+            <a:r>
+              <a:rPr sz="2000" b="0">
+                <a:solidFill>
+                  <a:srgbClr val="0F2445"/>
+                </a:solidFill>
+                <a:latin typeface="Poppins"/>
+              </a:rPr>
+              <a:t>Aged 65+: 46% vs 21%</a:t>
+            </a:r>
+          </a:p>
+        </p:txBody>
+      </p:sp>
+      <p:sp>
+        <p:nvSpPr>
+          <p:cNvPr id="16" name="TextBox 15"/>
+          <p:cNvSpPr txBox="1"/>
+          <p:nvPr/>
+        </p:nvSpPr>
+        <p:spPr>
+          <a:xfrm>
+            <a:off x="548640" y="6355080"/>
+            <a:ext cx="11064240" cy="365760"/>
+          </a:xfrm>
+          <a:prstGeom prst="rect">
+            <a:avLst/>
+          </a:prstGeom>
+          <a:noFill/>
+        </p:spPr>
+        <p:txBody>
+          <a:bodyPr wrap="square" lIns="0" rIns="0" tIns="0" bIns="0" anchor="t">
+            <a:spAutoFit/>
+          </a:bodyPr>
+          <a:lstStyle/>
+          <a:p>
+            <a:pPr algn="l"/>
+            <a:r>
+              <a:rPr sz="1800" b="0">
+                <a:solidFill>
+                  <a:srgbClr val="4A5A72"/>
+                </a:solidFill>
+                <a:latin typeface="Poppins"/>
+              </a:rPr>
+              <a:t>Source: Meta Ads, Meta-attributed purchases. Average $379 per buyer.</a:t>
+            </a:r>
+          </a:p>
+        </p:txBody>
+      </p:sp>
+    </p:spTree>
+  </p:cSld>
+  <p:clrMapOvr>
+    <a:masterClrMapping/>
+  </p:clrMapOvr>
+</p:sld>
+</file>
+
+<file path=ppt/slides/slide3.xml><?xml version="1.0" encoding="utf-8"?>
+<p:sld xmlns:a="http://schemas.openxmlformats.org/drawingml/2006/main" xmlns:p="http://schemas.openxmlformats.org/presentationml/2006/main" xmlns:r="http://schemas.openxmlformats.org/officeDocument/2006/relationships">
+  <p:cSld>
+    <p:spTree>
+      <p:nvGrpSpPr>
+        <p:cNvPr id="1" name=""/>
+        <p:cNvGrpSpPr/>
+        <p:nvPr/>
+      </p:nvGrpSpPr>
+      <p:grpSpPr/>
+      <p:sp>
+        <p:nvSpPr>
+          <p:cNvPr id="2" name="TextBox 1"/>
+          <p:cNvSpPr txBox="1"/>
+          <p:nvPr/>
+        </p:nvSpPr>
+        <p:spPr>
+          <a:xfrm>
+            <a:off x="548640" y="347472"/>
+            <a:ext cx="10972800" cy="365760"/>
+          </a:xfrm>
+          <a:prstGeom prst="rect">
+            <a:avLst/>
+          </a:prstGeom>
+          <a:noFill/>
+        </p:spPr>
+        <p:txBody>
+          <a:bodyPr wrap="square" lIns="0" rIns="0" tIns="0" bIns="0" anchor="t">
+            <a:spAutoFit/>
+          </a:bodyPr>
+          <a:lstStyle/>
+          <a:p>
+            <a:pPr algn="l"/>
+            <a:r>
+              <a:rPr sz="1800" b="1">
+                <a:solidFill>
+                  <a:srgbClr val="006EFF"/>
+                </a:solidFill>
+                <a:latin typeface="Poppins"/>
+              </a:rPr>
+              <a:t>Julie Masterclass · US only, ages 35 to 65+, top 10% income ZIP codes</a:t>
+            </a:r>
+          </a:p>
+        </p:txBody>
+      </p:sp>
+      <p:sp>
+        <p:nvSpPr>
+          <p:cNvPr id="3" name="TextBox 2"/>
+          <p:cNvSpPr txBox="1"/>
+          <p:nvPr/>
+        </p:nvSpPr>
+        <p:spPr>
+          <a:xfrm>
+            <a:off x="548640" y="713232"/>
+            <a:ext cx="11155680" cy="1097280"/>
+          </a:xfrm>
+          <a:prstGeom prst="rect">
+            <a:avLst/>
+          </a:prstGeom>
+          <a:noFill/>
+        </p:spPr>
+        <p:txBody>
+          <a:bodyPr wrap="square" lIns="0" rIns="0" tIns="0" bIns="0" anchor="t">
+            <a:spAutoFit/>
+          </a:bodyPr>
+          <a:lstStyle/>
+          <a:p>
+            <a:pPr algn="l"/>
+            <a:r>
+              <a:rPr sz="3200" b="1">
+                <a:solidFill>
+                  <a:srgbClr val="0F2445"/>
+                </a:solidFill>
+                <a:latin typeface="Poppins"/>
+              </a:rPr>
+              <a:t>Masterclass targeting: 41 Meta interests in 6 clusters, plus buyer lookalikes.</a:t>
             </a:r>
           </a:p>
         </p:txBody>

</xml_diff>